<commit_message>
Implementación de grafico 3D de rodrigues
</commit_message>
<xml_diff>
--- a/Poster2023.pptx
+++ b/Poster2023.pptx
@@ -3049,7 +3049,7 @@
         </p:nvSpPr>
         <p:spPr>
           <a:xfrm>
-            <a:off x="816985" y="21461566"/>
+            <a:off x="816985" y="21562315"/>
             <a:ext cx="15249378" cy="20862668"/>
           </a:xfrm>
           <a:prstGeom prst="roundRect">
@@ -6221,7 +6221,7 @@
         </p:nvSpPr>
         <p:spPr>
           <a:xfrm>
-            <a:off x="17271940" y="14183584"/>
+            <a:off x="17232023" y="14306777"/>
             <a:ext cx="13258800" cy="769441"/>
           </a:xfrm>
           <a:prstGeom prst="rect">
@@ -6522,8 +6522,8 @@
         </p:blipFill>
         <p:spPr>
           <a:xfrm>
-            <a:off x="7754960" y="33209683"/>
-            <a:ext cx="7470931" cy="1115931"/>
+            <a:off x="9213661" y="30944996"/>
+            <a:ext cx="6001095" cy="896382"/>
           </a:xfrm>
           <a:prstGeom prst="rect">
             <a:avLst/>
@@ -6552,8 +6552,8 @@
         </p:blipFill>
         <p:spPr>
           <a:xfrm>
-            <a:off x="1982715" y="37885613"/>
-            <a:ext cx="13232041" cy="2834923"/>
+            <a:off x="1520999" y="33440049"/>
+            <a:ext cx="10320027" cy="2211033"/>
           </a:xfrm>
           <a:prstGeom prst="rect">
             <a:avLst/>
@@ -6969,7 +6969,7 @@
         </p:blipFill>
         <p:spPr>
           <a:xfrm>
-            <a:off x="8101174" y="23796735"/>
+            <a:off x="8239718" y="22973400"/>
             <a:ext cx="6646312" cy="5988261"/>
           </a:xfrm>
           <a:prstGeom prst="rect">
@@ -6991,7 +6991,7 @@
         </p:nvSpPr>
         <p:spPr>
           <a:xfrm>
-            <a:off x="1528037" y="24133223"/>
+            <a:off x="1528037" y="23984271"/>
             <a:ext cx="13258800" cy="769441"/>
           </a:xfrm>
           <a:prstGeom prst="rect">
@@ -7030,7 +7030,7 @@
         </p:nvSpPr>
         <p:spPr>
           <a:xfrm>
-            <a:off x="1698180" y="25296093"/>
+            <a:off x="1698180" y="24885097"/>
             <a:ext cx="5386761" cy="914400"/>
           </a:xfrm>
           <a:prstGeom prst="rect">
@@ -7288,7 +7288,7 @@
         </p:nvSpPr>
         <p:spPr>
           <a:xfrm>
-            <a:off x="1672625" y="28086694"/>
+            <a:off x="1672625" y="27625355"/>
             <a:ext cx="5386761" cy="914400"/>
           </a:xfrm>
           <a:prstGeom prst="rect">
@@ -7497,7 +7497,7 @@
         </p:nvSpPr>
         <p:spPr>
           <a:xfrm>
-            <a:off x="5708264" y="30019351"/>
+            <a:off x="5708264" y="29023479"/>
             <a:ext cx="9506492" cy="1446550"/>
           </a:xfrm>
           <a:prstGeom prst="rect">
@@ -7543,7 +7543,7 @@
         </p:nvSpPr>
         <p:spPr>
           <a:xfrm>
-            <a:off x="1823222" y="31566136"/>
+            <a:off x="1772338" y="30098114"/>
             <a:ext cx="8348044" cy="1039617"/>
           </a:xfrm>
           <a:prstGeom prst="rect">
@@ -7676,7 +7676,7 @@
         </p:nvSpPr>
         <p:spPr>
           <a:xfrm>
-            <a:off x="1823222" y="36439862"/>
+            <a:off x="1822064" y="32355285"/>
             <a:ext cx="7772400" cy="457200"/>
           </a:xfrm>
           <a:prstGeom prst="rect">
@@ -7809,7 +7809,7 @@
         </p:nvSpPr>
         <p:spPr>
           <a:xfrm>
-            <a:off x="9575884" y="34261924"/>
+            <a:off x="10359308" y="31859539"/>
             <a:ext cx="4403176" cy="1189387"/>
           </a:xfrm>
           <a:prstGeom prst="rect">
@@ -7958,6 +7958,190 @@
               </a:rPr>
               <a:t> de Moore–Penrose</a:t>
             </a:r>
+          </a:p>
+        </p:txBody>
+      </p:sp>
+      <p:sp>
+        <p:nvSpPr>
+          <p:cNvPr id="13" name="CuadroTexto 12">
+            <a:extLst>
+              <a:ext uri="{FF2B5EF4-FFF2-40B4-BE49-F238E27FC236}">
+                <a16:creationId xmlns:a16="http://schemas.microsoft.com/office/drawing/2014/main" id="{CA93ABF1-D19F-FF6F-80AA-653567BEB1A3}"/>
+              </a:ext>
+            </a:extLst>
+          </p:cNvPr>
+          <p:cNvSpPr txBox="1"/>
+          <p:nvPr/>
+        </p:nvSpPr>
+        <p:spPr>
+          <a:xfrm>
+            <a:off x="1769474" y="36689937"/>
+            <a:ext cx="9506492" cy="1446550"/>
+          </a:xfrm>
+          <a:prstGeom prst="rect">
+            <a:avLst/>
+          </a:prstGeom>
+          <a:noFill/>
+        </p:spPr>
+        <p:txBody>
+          <a:bodyPr wrap="square" rtlCol="0">
+            <a:spAutoFit/>
+          </a:bodyPr>
+          <a:lstStyle/>
+          <a:p>
+            <a:pPr marL="571500" indent="-571500">
+              <a:buFont typeface="Arial" panose="020B0604020202020204" pitchFamily="34" charset="0"/>
+              <a:buChar char="•"/>
+            </a:pPr>
+            <a:r>
+              <a:rPr lang="es-MX" sz="4400" dirty="0"/>
+              <a:t>Método de </a:t>
+            </a:r>
+            <a:r>
+              <a:rPr lang="es-MX" sz="4400" dirty="0" err="1"/>
+              <a:t>Rodrigues</a:t>
+            </a:r>
+            <a:endParaRPr lang="es-MX" sz="4400" dirty="0"/>
+          </a:p>
+          <a:p>
+            <a:pPr marL="571500" indent="-571500">
+              <a:buFont typeface="Arial" panose="020B0604020202020204" pitchFamily="34" charset="0"/>
+              <a:buChar char="•"/>
+            </a:pPr>
+            <a:endParaRPr lang="es-MX" sz="4400" dirty="0"/>
+          </a:p>
+        </p:txBody>
+      </p:sp>
+      <p:sp>
+        <p:nvSpPr>
+          <p:cNvPr id="16" name="Text 116">
+            <a:extLst>
+              <a:ext uri="{FF2B5EF4-FFF2-40B4-BE49-F238E27FC236}">
+                <a16:creationId xmlns:a16="http://schemas.microsoft.com/office/drawing/2014/main" id="{44FB4C62-FC88-774E-BC28-9E1D6E565884}"/>
+              </a:ext>
+            </a:extLst>
+          </p:cNvPr>
+          <p:cNvSpPr/>
+          <p:nvPr/>
+        </p:nvSpPr>
+        <p:spPr>
+          <a:xfrm>
+            <a:off x="1822064" y="37931193"/>
+            <a:ext cx="8348044" cy="1039617"/>
+          </a:xfrm>
+          <a:prstGeom prst="rect">
+            <a:avLst/>
+          </a:prstGeom>
+          <a:noFill/>
+          <a:ln/>
+        </p:spPr>
+        <p:txBody>
+          <a:bodyPr wrap="square" lIns="0" tIns="0" rIns="0" bIns="0" rtlCol="0" anchor="ctr"/>
+          <a:lstStyle>
+            <a:lvl1pPr marL="0" algn="l" defTabSz="914400" rtl="0" eaLnBrk="1" latinLnBrk="0" hangingPunct="1">
+              <a:defRPr sz="1800" kern="1200">
+                <a:solidFill>
+                  <a:schemeClr val="tx1"/>
+                </a:solidFill>
+                <a:latin typeface="+mn-lt"/>
+                <a:ea typeface="+mn-ea"/>
+                <a:cs typeface="+mn-cs"/>
+              </a:defRPr>
+            </a:lvl1pPr>
+            <a:lvl2pPr marL="457200" algn="l" defTabSz="914400" rtl="0" eaLnBrk="1" latinLnBrk="0" hangingPunct="1">
+              <a:defRPr sz="1800" kern="1200">
+                <a:solidFill>
+                  <a:schemeClr val="tx1"/>
+                </a:solidFill>
+                <a:latin typeface="+mn-lt"/>
+                <a:ea typeface="+mn-ea"/>
+                <a:cs typeface="+mn-cs"/>
+              </a:defRPr>
+            </a:lvl2pPr>
+            <a:lvl3pPr marL="914400" algn="l" defTabSz="914400" rtl="0" eaLnBrk="1" latinLnBrk="0" hangingPunct="1">
+              <a:defRPr sz="1800" kern="1200">
+                <a:solidFill>
+                  <a:schemeClr val="tx1"/>
+                </a:solidFill>
+                <a:latin typeface="+mn-lt"/>
+                <a:ea typeface="+mn-ea"/>
+                <a:cs typeface="+mn-cs"/>
+              </a:defRPr>
+            </a:lvl3pPr>
+            <a:lvl4pPr marL="1371600" algn="l" defTabSz="914400" rtl="0" eaLnBrk="1" latinLnBrk="0" hangingPunct="1">
+              <a:defRPr sz="1800" kern="1200">
+                <a:solidFill>
+                  <a:schemeClr val="tx1"/>
+                </a:solidFill>
+                <a:latin typeface="+mn-lt"/>
+                <a:ea typeface="+mn-ea"/>
+                <a:cs typeface="+mn-cs"/>
+              </a:defRPr>
+            </a:lvl4pPr>
+            <a:lvl5pPr marL="1828800" algn="l" defTabSz="914400" rtl="0" eaLnBrk="1" latinLnBrk="0" hangingPunct="1">
+              <a:defRPr sz="1800" kern="1200">
+                <a:solidFill>
+                  <a:schemeClr val="tx1"/>
+                </a:solidFill>
+                <a:latin typeface="+mn-lt"/>
+                <a:ea typeface="+mn-ea"/>
+                <a:cs typeface="+mn-cs"/>
+              </a:defRPr>
+            </a:lvl5pPr>
+            <a:lvl6pPr marL="2286000" algn="l" defTabSz="914400" rtl="0" eaLnBrk="1" latinLnBrk="0" hangingPunct="1">
+              <a:defRPr sz="1800" kern="1200">
+                <a:solidFill>
+                  <a:schemeClr val="tx1"/>
+                </a:solidFill>
+                <a:latin typeface="+mn-lt"/>
+                <a:ea typeface="+mn-ea"/>
+                <a:cs typeface="+mn-cs"/>
+              </a:defRPr>
+            </a:lvl6pPr>
+            <a:lvl7pPr marL="2743200" algn="l" defTabSz="914400" rtl="0" eaLnBrk="1" latinLnBrk="0" hangingPunct="1">
+              <a:defRPr sz="1800" kern="1200">
+                <a:solidFill>
+                  <a:schemeClr val="tx1"/>
+                </a:solidFill>
+                <a:latin typeface="+mn-lt"/>
+                <a:ea typeface="+mn-ea"/>
+                <a:cs typeface="+mn-cs"/>
+              </a:defRPr>
+            </a:lvl7pPr>
+            <a:lvl8pPr marL="3200400" algn="l" defTabSz="914400" rtl="0" eaLnBrk="1" latinLnBrk="0" hangingPunct="1">
+              <a:defRPr sz="1800" kern="1200">
+                <a:solidFill>
+                  <a:schemeClr val="tx1"/>
+                </a:solidFill>
+                <a:latin typeface="+mn-lt"/>
+                <a:ea typeface="+mn-ea"/>
+                <a:cs typeface="+mn-cs"/>
+              </a:defRPr>
+            </a:lvl8pPr>
+            <a:lvl9pPr marL="3657600" algn="l" defTabSz="914400" rtl="0" eaLnBrk="1" latinLnBrk="0" hangingPunct="1">
+              <a:defRPr sz="1800" kern="1200">
+                <a:solidFill>
+                  <a:schemeClr val="tx1"/>
+                </a:solidFill>
+                <a:latin typeface="+mn-lt"/>
+                <a:ea typeface="+mn-ea"/>
+                <a:cs typeface="+mn-cs"/>
+              </a:defRPr>
+            </a:lvl9pPr>
+          </a:lstStyle>
+          <a:p>
+            <a:r>
+              <a:rPr lang="es-MX" sz="3200" dirty="0"/>
+              <a:t>Para corregir las mediciones se define un modelo de transformación afín expresado como</a:t>
+            </a:r>
+            <a:endParaRPr lang="en-US" sz="3200" dirty="0">
+              <a:solidFill>
+                <a:schemeClr val="tx1">
+                  <a:lumMod val="95000"/>
+                  <a:lumOff val="5000"/>
+                </a:schemeClr>
+              </a:solidFill>
+            </a:endParaRPr>
           </a:p>
         </p:txBody>
       </p:sp>

</xml_diff>